<commit_message>
docs(submission): 8-slide deck, submission video end card and platform form text [TASK-044 TASK-045 TASK-046]
- Deck: add an engineering-depth slide; replace internal UNKNOWN /
  LINK-CHECK lines on slides 1 and 7 with judge-facing copy. Claims
  check updated to the organiser's 8-slide limit; 64/64 PASS.
- Video: final-submission.mp4 re-renders only the closing card
  (t >= 97 s) so it no longer says "Round 2 NOT submitted";
  final.mp4 and its provenance are unchanged.
- platform-submission.md: field-by-field text for the
  h4hbd.ezassist.me upload form and a submission record.
- PHASE_4 tracker: organiser instructions and 18 Oct re-verification.

Co-Authored-By: Claude Opus 5.5 <noreply@anthropic.com>
Claude-Session: https://claude.ai/code/session_012PG3NKTfzjFC6S6eARgJq1
</commit_message>
<xml_diff>
--- a/submission/round2/fera-round2-deck.pptx
+++ b/submission/round2/fera-round2-deck.pptx
@@ -12,6 +12,7 @@
     <p:sldId id="260" r:id="rId12"/>
     <p:sldId id="261" r:id="rId13"/>
     <p:sldId id="262" r:id="rId14"/>
+    <p:sldId id="263" r:id="rId15"/>
   </p:sldIdLst>
   <p:sldSz cx="12191695" cy="6858000" type="screen4x3"/>
   <p:notesSz cx="6858000" cy="9144000"/>
@@ -514,7 +515,7 @@
           <a:p/>
           <a:p>
             <a:r>
-              <a:t>Honest copy: the title avoids alert/rescue/police/CID claims. Working baseline is 14 Oct 2026 22:00; organiser extension cutoff/date/email/formats are UNKNOWN. No claim of deployed URL.</a:t>
+              <a:t>Honest copy: the title avoids alert/rescue/police/CID claims. Prepared for the 18 Oct 2026 22:00 (GMT+6) prototype submission on the organiser platform. No claim of deployed URL.</a:t>
             </a:r>
           </a:p>
         </p:txBody>
@@ -964,13 +965,89 @@
           <a:lstStyle/>
           <a:p>
             <a:r>
+              <a:t>Sources: README.md status block; package.json scripts; find src/app -name page.tsx (16); find src/app/api -name route.ts (22); db/schema_v2.sql; CI run 39116451104.</a:t>
+            </a:r>
+          </a:p>
+          <a:p/>
+          <a:p>
+            <a:r>
+              <a:t>Plain wording: these are software checks on synthetic data. They do not establish human acceptance, production readiness or matcher quality at release level.</a:t>
+            </a:r>
+          </a:p>
+        </p:txBody>
+      </p:sp>
+      <p:sp>
+        <p:nvSpPr>
+          <p:cNvPr id="4" name="Slide Number Placeholder 3"/>
+          <p:cNvSpPr>
+            <a:spLocks noGrp="1"/>
+          </p:cNvSpPr>
+          <p:nvPr>
+            <p:ph type="sldNum" idx="5" sz="quarter"/>
+          </p:nvPr>
+        </p:nvSpPr>
+        <p:spPr/>
+      </p:sp>
+    </p:spTree>
+  </p:cSld>
+  <p:clrMapOvr>
+    <a:masterClrMapping/>
+  </p:clrMapOvr>
+</p:notes>
+</file>
+
+<file path=ppt/notesSlides/notesSlide8.xml><?xml version="1.0" encoding="utf-8"?>
+<p:notes xmlns:a="http://schemas.openxmlformats.org/drawingml/2006/main" xmlns:p="http://schemas.openxmlformats.org/presentationml/2006/main" xmlns:r="http://schemas.openxmlformats.org/officeDocument/2006/relationships">
+  <p:cSld>
+    <p:spTree>
+      <p:nvGrpSpPr>
+        <p:cNvPr id="1" name=""/>
+        <p:cNvGrpSpPr/>
+        <p:nvPr/>
+      </p:nvGrpSpPr>
+      <p:grpSpPr>
+        <a:xfrm>
+          <a:off x="0" y="0"/>
+          <a:ext cx="0" cy="0"/>
+          <a:chOff x="0" y="0"/>
+          <a:chExt cx="0" cy="0"/>
+        </a:xfrm>
+      </p:grpSpPr>
+      <p:sp>
+        <p:nvSpPr>
+          <p:cNvPr id="2" name="Slide Image Placeholder 1"/>
+          <p:cNvSpPr>
+            <a:spLocks noGrp="1"/>
+          </p:cNvSpPr>
+          <p:nvPr>
+            <p:ph type="sldImg" idx="2"/>
+          </p:nvPr>
+        </p:nvSpPr>
+        <p:spPr/>
+      </p:sp>
+      <p:sp>
+        <p:nvSpPr>
+          <p:cNvPr id="3" name="Notes Placeholder 2"/>
+          <p:cNvSpPr>
+            <a:spLocks noGrp="1"/>
+          </p:cNvSpPr>
+          <p:nvPr>
+            <p:ph type="body" idx="3" sz="quarter"/>
+          </p:nvPr>
+        </p:nvSpPr>
+        <p:spPr/>
+        <p:txBody>
+          <a:bodyPr/>
+          <a:lstStyle/>
+          <a:p>
+            <a:r>
               <a:t>Sources: D7 §4 (OQ list); PHASE_4_SUBMISSION.md AMD-4-1; AGENTS.md Principles VI and VII.</a:t>
             </a:r>
           </a:p>
           <a:p/>
           <a:p>
             <a:r>
-              <a:t>Plain wording: nothing is presented as a result that has not been measured. TASK-045 demo footage, production, gate clearance, upload and submission remain blocked until the working build is signed off and organiser evidence is recorded.</a:t>
+              <a:t>Plain wording: nothing is presented as a result that has not been measured. Production deployment, frozen evaluation and human studies are next steps, not completed work.</a:t>
             </a:r>
           </a:p>
         </p:txBody>
@@ -4489,7 +4566,7 @@
                 </a:solidFill>
                 <a:latin typeface="Inter"/>
               </a:rPr>
-              <a:t>Round 2 working baseline 14 Oct 2026 · Organiser cutoff UNKNOWN · Built for review, not for delivery</a:t>
+              <a:t>Hack for Humanity Bangladesh 2026 · Synthetic-data prototype · Built for review, not for delivery</a:t>
             </a:r>
           </a:p>
         </p:txBody>
@@ -8427,7 +8504,7 @@
                 </a:solidFill>
                 <a:latin typeface="Inter"/>
               </a:rPr>
-              <a:t>LIMITATIONS AND NEXT STEPS</a:t>
+              <a:t>WHAT WE BUILT · SYNTHETIC DATA</a:t>
             </a:r>
           </a:p>
         </p:txBody>
@@ -8462,7 +8539,7 @@
                 </a:solidFill>
                 <a:latin typeface="Inter"/>
               </a:rPr>
-              <a:t>What this prototype does not do, and what comes next.</a:t>
+              <a:t>A working app, tested end to end on synthetic records.</a:t>
             </a:r>
           </a:p>
         </p:txBody>
@@ -8475,8 +8552,8 @@
         </p:nvSpPr>
         <p:spPr>
           <a:xfrm>
-            <a:off x="822960" y="2286000"/>
-            <a:ext cx="5303520" cy="4023360"/>
+            <a:off x="822960" y="2194560"/>
+            <a:ext cx="5303520" cy="3566160"/>
           </a:xfrm>
           <a:prstGeom prst="rect">
             <a:avLst/>
@@ -8521,7 +8598,7 @@
         </p:nvSpPr>
         <p:spPr>
           <a:xfrm>
-            <a:off x="1005840" y="2468880"/>
+            <a:off x="1005840" y="2377440"/>
             <a:ext cx="4937760" cy="365760"/>
           </a:xfrm>
           <a:prstGeom prst="rect">
@@ -8539,11 +8616,11 @@
             <a:r>
               <a:rPr sz="1100" b="1" i="0">
                 <a:solidFill>
-                  <a:srgbClr val="FFC533"/>
-                </a:solidFill>
-                <a:latin typeface="Inter"/>
-              </a:rPr>
-              <a:t>Limitations</a:t>
+                  <a:srgbClr val="57C1FF"/>
+                </a:solidFill>
+                <a:latin typeface="Inter"/>
+              </a:rPr>
+              <a:t>In the repository</a:t>
             </a:r>
           </a:p>
         </p:txBody>
@@ -8556,8 +8633,8 @@
         </p:nvSpPr>
         <p:spPr>
           <a:xfrm>
-            <a:off x="1005840" y="2926080"/>
-            <a:ext cx="4937760" cy="3200400"/>
+            <a:off x="1005840" y="2834640"/>
+            <a:ext cx="4937760" cy="2743200"/>
           </a:xfrm>
           <a:prstGeom prst="rect">
             <a:avLst/>
@@ -8578,7 +8655,7 @@
                 </a:solidFill>
                 <a:latin typeface="Inter"/>
               </a:rPr>
-              <a:t>•  Synthetic data only — no real child records, faces or coordinates.</a:t>
+              <a:t>•  16 screens for parents, staff, officers and admins; Bangla and English.</a:t>
             </a:r>
           </a:p>
           <a:p>
@@ -8590,7 +8667,7 @@
                 </a:solidFill>
                 <a:latin typeface="Inter"/>
               </a:rPr>
-              <a:t>•  Officer verification is [MOCK]; referral is a recorded simulation.</a:t>
+              <a:t>•  22 API routes: Zod input, role guard, per-role DTO, error envelope.</a:t>
             </a:r>
           </a:p>
           <a:p>
@@ -8602,7 +8679,7 @@
                 </a:solidFill>
                 <a:latin typeface="Inter"/>
               </a:rPr>
-              <a:t>•  Live AI provider availability and account configuration are unverified.</a:t>
+              <a:t>•  PostgreSQL 16 + pgvector in hand-written SQL; one-transaction confirm; append-only audit.</a:t>
             </a:r>
           </a:p>
           <a:p>
@@ -8614,7 +8691,7 @@
                 </a:solidFill>
                 <a:latin typeface="Inter"/>
               </a:rPr>
-              <a:t>•  Voice intake supports PCM WAV only; webm is unsupported.</a:t>
+              <a:t>•  Matcher: hard filters, multilingual-e5-small similarity, readable reasons.</a:t>
             </a:r>
           </a:p>
           <a:p>
@@ -8626,7 +8703,7 @@
                 </a:solidFill>
                 <a:latin typeface="Inter"/>
               </a:rPr>
-              <a:t>•  Cached outputs [MOCK] are labelled and never hidden.</a:t>
+              <a:t>•  Bangla normaliser; LLM and speech adapters with labelled fallback.</a:t>
             </a:r>
           </a:p>
           <a:p>
@@ -8638,7 +8715,7 @@
                 </a:solidFill>
                 <a:latin typeface="Inter"/>
               </a:rPr>
-              <a:t>•  No alert, runaway, rescue, police/CID-integration or legal-compliance claim.</a:t>
+              <a:t>•  Duplicate detection; 64-district counts with an accessible table.</a:t>
             </a:r>
           </a:p>
         </p:txBody>
@@ -8651,8 +8728,8 @@
         </p:nvSpPr>
         <p:spPr>
           <a:xfrm>
-            <a:off x="6400800" y="2286000"/>
-            <a:ext cx="5303520" cy="4023360"/>
+            <a:off x="6400800" y="2194560"/>
+            <a:ext cx="5303520" cy="3566160"/>
           </a:xfrm>
           <a:prstGeom prst="rect">
             <a:avLst/>
@@ -8697,7 +8774,7 @@
         </p:nvSpPr>
         <p:spPr>
           <a:xfrm>
-            <a:off x="6583680" y="2468880"/>
+            <a:off x="6583680" y="2377440"/>
             <a:ext cx="4937760" cy="365760"/>
           </a:xfrm>
           <a:prstGeom prst="rect">
@@ -8715,11 +8792,11 @@
             <a:r>
               <a:rPr sz="1100" b="1" i="0">
                 <a:solidFill>
-                  <a:srgbClr val="57C1FF"/>
-                </a:solidFill>
-                <a:latin typeface="Inter"/>
-              </a:rPr>
-              <a:t>Next steps</a:t>
+                  <a:srgbClr val="59D499"/>
+                </a:solidFill>
+                <a:latin typeface="Inter"/>
+              </a:rPr>
+              <a:t>How it is checked</a:t>
             </a:r>
           </a:p>
         </p:txBody>
@@ -8732,8 +8809,8 @@
         </p:nvSpPr>
         <p:spPr>
           <a:xfrm>
-            <a:off x="6583680" y="2926080"/>
-            <a:ext cx="4937760" cy="3200400"/>
+            <a:off x="6583680" y="2834640"/>
+            <a:ext cx="4937760" cy="2743200"/>
           </a:xfrm>
           <a:prstGeom prst="rect">
             <a:avLst/>
@@ -8754,6 +8831,570 @@
                 </a:solidFill>
                 <a:latin typeface="Inter"/>
               </a:rPr>
+              <a:t>•  3,693 unit tests pass (308 skipped).</a:t>
+            </a:r>
+          </a:p>
+          <a:p>
+            <a:pPr algn="l"/>
+            <a:r>
+              <a:rPr sz="1200" b="0" i="0">
+                <a:solidFill>
+                  <a:srgbClr val="CDCDCD"/>
+                </a:solidFill>
+                <a:latin typeface="Inter"/>
+              </a:rPr>
+              <a:t>•  320 PostgreSQL + pgvector tests pass, fresh database per file.</a:t>
+            </a:r>
+          </a:p>
+          <a:p>
+            <a:pPr algn="l"/>
+            <a:r>
+              <a:rPr sz="1200" b="0" i="0">
+                <a:solidFill>
+                  <a:srgbClr val="CDCDCD"/>
+                </a:solidFill>
+                <a:latin typeface="Inter"/>
+              </a:rPr>
+              <a:t>•  78 Playwright + axe browser checks pass (desktop and mobile emulation).</a:t>
+            </a:r>
+          </a:p>
+          <a:p>
+            <a:pPr algn="l"/>
+            <a:r>
+              <a:rPr sz="1200" b="0" i="0">
+                <a:solidFill>
+                  <a:srgbClr val="CDCDCD"/>
+                </a:solidFill>
+                <a:latin typeface="Inter"/>
+              </a:rPr>
+              <a:t>•  Strict TypeScript; lint 0 errors; remote CI green.</a:t>
+            </a:r>
+          </a:p>
+          <a:p>
+            <a:pPr algn="l"/>
+            <a:r>
+              <a:rPr sz="1200" b="0" i="0">
+                <a:solidFill>
+                  <a:srgbClr val="CDCDCD"/>
+                </a:solidFill>
+                <a:latin typeface="Inter"/>
+              </a:rPr>
+              <a:t>•  Eleven specialist reviews, with a safeguarding gate on every PR.</a:t>
+            </a:r>
+          </a:p>
+          <a:p>
+            <a:pPr algn="l"/>
+            <a:r>
+              <a:rPr sz="1200" b="0" i="0">
+                <a:solidFill>
+                  <a:srgbClr val="CDCDCD"/>
+                </a:solidFill>
+                <a:latin typeface="Inter"/>
+              </a:rPr>
+              <a:t>•  Software checks only: no human study or production run yet.</a:t>
+            </a:r>
+          </a:p>
+        </p:txBody>
+      </p:sp>
+      <p:sp>
+        <p:nvSpPr>
+          <p:cNvPr id="11" name="TextBox 10"/>
+          <p:cNvSpPr txBox="1"/>
+          <p:nvPr/>
+        </p:nvSpPr>
+        <p:spPr>
+          <a:xfrm>
+            <a:off x="822960" y="5897880"/>
+            <a:ext cx="10515600" cy="320040"/>
+          </a:xfrm>
+          <a:prstGeom prst="rect">
+            <a:avLst/>
+          </a:prstGeom>
+          <a:noFill/>
+        </p:spPr>
+        <p:txBody>
+          <a:bodyPr wrap="square" lIns="0" rIns="0" tIns="0" bIns="0" anchor="t">
+            <a:spAutoFit/>
+          </a:bodyPr>
+          <a:lstStyle/>
+          <a:p>
+            <a:pPr algn="l"/>
+            <a:r>
+              <a:rPr sz="1100" b="0" i="0">
+                <a:solidFill>
+                  <a:srgbClr val="9C9C9D"/>
+                </a:solidFill>
+                <a:latin typeface="Inter"/>
+              </a:rPr>
+              <a:t>Team: Mahim (lead, platform) · Obidit (intake, AI, outputs) · Masnun (data, matching, officer workflow)</a:t>
+            </a:r>
+          </a:p>
+        </p:txBody>
+      </p:sp>
+      <p:sp>
+        <p:nvSpPr>
+          <p:cNvPr id="12" name="TextBox 11"/>
+          <p:cNvSpPr txBox="1"/>
+          <p:nvPr/>
+        </p:nvSpPr>
+        <p:spPr>
+          <a:xfrm>
+            <a:off x="822960" y="6144768"/>
+            <a:ext cx="10515600" cy="274320"/>
+          </a:xfrm>
+          <a:prstGeom prst="rect">
+            <a:avLst/>
+          </a:prstGeom>
+          <a:noFill/>
+        </p:spPr>
+        <p:txBody>
+          <a:bodyPr wrap="square" lIns="0" rIns="0" tIns="0" bIns="0" anchor="t">
+            <a:spAutoFit/>
+          </a:bodyPr>
+          <a:lstStyle/>
+          <a:p>
+            <a:pPr algn="l"/>
+            <a:r>
+              <a:rPr sz="900" b="0" i="1">
+                <a:solidFill>
+                  <a:srgbClr val="6A6B6C"/>
+                </a:solidFill>
+                <a:latin typeface="Inter"/>
+              </a:rPr>
+              <a:t>Counts: README verification at application commit 9155963 and remote CI; typecheck, lint and unit re-run 18 Oct 2026.</a:t>
+            </a:r>
+          </a:p>
+        </p:txBody>
+      </p:sp>
+    </p:spTree>
+  </p:cSld>
+  <p:clrMapOvr>
+    <a:masterClrMapping/>
+  </p:clrMapOvr>
+</p:sld>
+</file>
+
+<file path=ppt/slides/slide8.xml><?xml version="1.0" encoding="utf-8"?>
+<p:sld xmlns:a="http://schemas.openxmlformats.org/drawingml/2006/main" xmlns:p="http://schemas.openxmlformats.org/presentationml/2006/main" xmlns:r="http://schemas.openxmlformats.org/officeDocument/2006/relationships">
+  <p:cSld>
+    <p:bg>
+      <p:bgPr>
+        <a:solidFill>
+          <a:srgbClr val="07080A"/>
+        </a:solidFill>
+        <a:effectLst/>
+      </p:bgPr>
+    </p:bg>
+    <p:spTree>
+      <p:nvGrpSpPr>
+        <p:cNvPr id="1" name=""/>
+        <p:cNvGrpSpPr/>
+        <p:nvPr/>
+      </p:nvGrpSpPr>
+      <p:grpSpPr/>
+      <p:sp>
+        <p:nvSpPr>
+          <p:cNvPr id="2" name="Rectangle 1"/>
+          <p:cNvSpPr/>
+          <p:nvPr/>
+        </p:nvSpPr>
+        <p:spPr>
+          <a:xfrm>
+            <a:off x="457200" y="457200"/>
+            <a:ext cx="11277295" cy="5943600"/>
+          </a:xfrm>
+          <a:prstGeom prst="rect">
+            <a:avLst/>
+          </a:prstGeom>
+          <a:solidFill>
+            <a:srgbClr val="07080A"/>
+          </a:solidFill>
+          <a:ln w="6350">
+            <a:solidFill>
+              <a:srgbClr val="242728"/>
+            </a:solidFill>
+          </a:ln>
+          <a:effectLst/>
+        </p:spPr>
+        <p:style>
+          <a:lnRef idx="1">
+            <a:schemeClr val="accent1"/>
+          </a:lnRef>
+          <a:fillRef idx="3">
+            <a:schemeClr val="accent1"/>
+          </a:fillRef>
+          <a:effectRef idx="2">
+            <a:schemeClr val="accent1"/>
+          </a:effectRef>
+          <a:fontRef idx="minor">
+            <a:schemeClr val="lt1"/>
+          </a:fontRef>
+        </p:style>
+        <p:txBody>
+          <a:bodyPr rtlCol="0" anchor="ctr"/>
+          <a:lstStyle/>
+          <a:p>
+            <a:pPr algn="ctr"/>
+          </a:p>
+        </p:txBody>
+      </p:sp>
+      <p:sp>
+        <p:nvSpPr>
+          <p:cNvPr id="3" name="TextBox 2"/>
+          <p:cNvSpPr txBox="1"/>
+          <p:nvPr/>
+        </p:nvSpPr>
+        <p:spPr>
+          <a:xfrm>
+            <a:off x="822960" y="822960"/>
+            <a:ext cx="10515600" cy="320040"/>
+          </a:xfrm>
+          <a:prstGeom prst="rect">
+            <a:avLst/>
+          </a:prstGeom>
+          <a:noFill/>
+        </p:spPr>
+        <p:txBody>
+          <a:bodyPr wrap="square" lIns="0" rIns="0" tIns="0" bIns="0" anchor="t">
+            <a:spAutoFit/>
+          </a:bodyPr>
+          <a:lstStyle/>
+          <a:p>
+            <a:pPr algn="l"/>
+            <a:r>
+              <a:rPr sz="1100" b="1" i="0">
+                <a:solidFill>
+                  <a:srgbClr val="6A6B6C"/>
+                </a:solidFill>
+                <a:latin typeface="Inter"/>
+              </a:rPr>
+              <a:t>LIMITATIONS AND NEXT STEPS</a:t>
+            </a:r>
+          </a:p>
+        </p:txBody>
+      </p:sp>
+      <p:sp>
+        <p:nvSpPr>
+          <p:cNvPr id="4" name="TextBox 3"/>
+          <p:cNvSpPr txBox="1"/>
+          <p:nvPr/>
+        </p:nvSpPr>
+        <p:spPr>
+          <a:xfrm>
+            <a:off x="822960" y="1234440"/>
+            <a:ext cx="10515600" cy="822960"/>
+          </a:xfrm>
+          <a:prstGeom prst="rect">
+            <a:avLst/>
+          </a:prstGeom>
+          <a:noFill/>
+        </p:spPr>
+        <p:txBody>
+          <a:bodyPr wrap="square" lIns="0" rIns="0" tIns="0" bIns="0" anchor="t">
+            <a:spAutoFit/>
+          </a:bodyPr>
+          <a:lstStyle/>
+          <a:p>
+            <a:pPr algn="l"/>
+            <a:r>
+              <a:rPr sz="2600" b="1" i="0">
+                <a:solidFill>
+                  <a:srgbClr val="F4F4F6"/>
+                </a:solidFill>
+                <a:latin typeface="Inter"/>
+              </a:rPr>
+              <a:t>What this prototype does not do, and what comes next.</a:t>
+            </a:r>
+          </a:p>
+        </p:txBody>
+      </p:sp>
+      <p:sp>
+        <p:nvSpPr>
+          <p:cNvPr id="5" name="Rectangle 4"/>
+          <p:cNvSpPr/>
+          <p:nvPr/>
+        </p:nvSpPr>
+        <p:spPr>
+          <a:xfrm>
+            <a:off x="822960" y="2286000"/>
+            <a:ext cx="5303520" cy="4023360"/>
+          </a:xfrm>
+          <a:prstGeom prst="rect">
+            <a:avLst/>
+          </a:prstGeom>
+          <a:solidFill>
+            <a:srgbClr val="0D0D0D"/>
+          </a:solidFill>
+          <a:ln>
+            <a:solidFill>
+              <a:srgbClr val="242728"/>
+            </a:solidFill>
+          </a:ln>
+          <a:effectLst/>
+        </p:spPr>
+        <p:style>
+          <a:lnRef idx="1">
+            <a:schemeClr val="accent1"/>
+          </a:lnRef>
+          <a:fillRef idx="3">
+            <a:schemeClr val="accent1"/>
+          </a:fillRef>
+          <a:effectRef idx="2">
+            <a:schemeClr val="accent1"/>
+          </a:effectRef>
+          <a:fontRef idx="minor">
+            <a:schemeClr val="lt1"/>
+          </a:fontRef>
+        </p:style>
+        <p:txBody>
+          <a:bodyPr rtlCol="0" anchor="ctr"/>
+          <a:lstStyle/>
+          <a:p>
+            <a:pPr algn="ctr"/>
+          </a:p>
+        </p:txBody>
+      </p:sp>
+      <p:sp>
+        <p:nvSpPr>
+          <p:cNvPr id="6" name="TextBox 5"/>
+          <p:cNvSpPr txBox="1"/>
+          <p:nvPr/>
+        </p:nvSpPr>
+        <p:spPr>
+          <a:xfrm>
+            <a:off x="1005840" y="2468880"/>
+            <a:ext cx="4937760" cy="365760"/>
+          </a:xfrm>
+          <a:prstGeom prst="rect">
+            <a:avLst/>
+          </a:prstGeom>
+          <a:noFill/>
+        </p:spPr>
+        <p:txBody>
+          <a:bodyPr wrap="square" lIns="0" rIns="0" tIns="0" bIns="0" anchor="t">
+            <a:spAutoFit/>
+          </a:bodyPr>
+          <a:lstStyle/>
+          <a:p>
+            <a:pPr algn="l"/>
+            <a:r>
+              <a:rPr sz="1100" b="1" i="0">
+                <a:solidFill>
+                  <a:srgbClr val="FFC533"/>
+                </a:solidFill>
+                <a:latin typeface="Inter"/>
+              </a:rPr>
+              <a:t>Limitations</a:t>
+            </a:r>
+          </a:p>
+        </p:txBody>
+      </p:sp>
+      <p:sp>
+        <p:nvSpPr>
+          <p:cNvPr id="7" name="TextBox 6"/>
+          <p:cNvSpPr txBox="1"/>
+          <p:nvPr/>
+        </p:nvSpPr>
+        <p:spPr>
+          <a:xfrm>
+            <a:off x="1005840" y="2926080"/>
+            <a:ext cx="4937760" cy="3200400"/>
+          </a:xfrm>
+          <a:prstGeom prst="rect">
+            <a:avLst/>
+          </a:prstGeom>
+          <a:noFill/>
+        </p:spPr>
+        <p:txBody>
+          <a:bodyPr wrap="square" lIns="0" rIns="0" tIns="0" bIns="0" anchor="t">
+            <a:spAutoFit/>
+          </a:bodyPr>
+          <a:lstStyle/>
+          <a:p>
+            <a:pPr algn="l"/>
+            <a:r>
+              <a:rPr sz="1200" b="0" i="0">
+                <a:solidFill>
+                  <a:srgbClr val="CDCDCD"/>
+                </a:solidFill>
+                <a:latin typeface="Inter"/>
+              </a:rPr>
+              <a:t>•  Synthetic data only — no real child records, faces or coordinates.</a:t>
+            </a:r>
+          </a:p>
+          <a:p>
+            <a:pPr algn="l"/>
+            <a:r>
+              <a:rPr sz="1200" b="0" i="0">
+                <a:solidFill>
+                  <a:srgbClr val="CDCDCD"/>
+                </a:solidFill>
+                <a:latin typeface="Inter"/>
+              </a:rPr>
+              <a:t>•  Officer verification is [MOCK]; referral is a recorded simulation.</a:t>
+            </a:r>
+          </a:p>
+          <a:p>
+            <a:pPr algn="l"/>
+            <a:r>
+              <a:rPr sz="1200" b="0" i="0">
+                <a:solidFill>
+                  <a:srgbClr val="CDCDCD"/>
+                </a:solidFill>
+                <a:latin typeface="Inter"/>
+              </a:rPr>
+              <a:t>•  Live AI provider availability and account configuration are unverified.</a:t>
+            </a:r>
+          </a:p>
+          <a:p>
+            <a:pPr algn="l"/>
+            <a:r>
+              <a:rPr sz="1200" b="0" i="0">
+                <a:solidFill>
+                  <a:srgbClr val="CDCDCD"/>
+                </a:solidFill>
+                <a:latin typeface="Inter"/>
+              </a:rPr>
+              <a:t>•  Voice intake supports PCM WAV only; webm is unsupported.</a:t>
+            </a:r>
+          </a:p>
+          <a:p>
+            <a:pPr algn="l"/>
+            <a:r>
+              <a:rPr sz="1200" b="0" i="0">
+                <a:solidFill>
+                  <a:srgbClr val="CDCDCD"/>
+                </a:solidFill>
+                <a:latin typeface="Inter"/>
+              </a:rPr>
+              <a:t>•  Cached outputs [MOCK] are labelled and never hidden.</a:t>
+            </a:r>
+          </a:p>
+          <a:p>
+            <a:pPr algn="l"/>
+            <a:r>
+              <a:rPr sz="1200" b="0" i="0">
+                <a:solidFill>
+                  <a:srgbClr val="CDCDCD"/>
+                </a:solidFill>
+                <a:latin typeface="Inter"/>
+              </a:rPr>
+              <a:t>•  No alert, runaway, rescue, police/CID-integration or legal-compliance claim.</a:t>
+            </a:r>
+          </a:p>
+        </p:txBody>
+      </p:sp>
+      <p:sp>
+        <p:nvSpPr>
+          <p:cNvPr id="8" name="Rectangle 7"/>
+          <p:cNvSpPr/>
+          <p:nvPr/>
+        </p:nvSpPr>
+        <p:spPr>
+          <a:xfrm>
+            <a:off x="6400800" y="2286000"/>
+            <a:ext cx="5303520" cy="4023360"/>
+          </a:xfrm>
+          <a:prstGeom prst="rect">
+            <a:avLst/>
+          </a:prstGeom>
+          <a:solidFill>
+            <a:srgbClr val="0D0D0D"/>
+          </a:solidFill>
+          <a:ln>
+            <a:solidFill>
+              <a:srgbClr val="242728"/>
+            </a:solidFill>
+          </a:ln>
+          <a:effectLst/>
+        </p:spPr>
+        <p:style>
+          <a:lnRef idx="1">
+            <a:schemeClr val="accent1"/>
+          </a:lnRef>
+          <a:fillRef idx="3">
+            <a:schemeClr val="accent1"/>
+          </a:fillRef>
+          <a:effectRef idx="2">
+            <a:schemeClr val="accent1"/>
+          </a:effectRef>
+          <a:fontRef idx="minor">
+            <a:schemeClr val="lt1"/>
+          </a:fontRef>
+        </p:style>
+        <p:txBody>
+          <a:bodyPr rtlCol="0" anchor="ctr"/>
+          <a:lstStyle/>
+          <a:p>
+            <a:pPr algn="ctr"/>
+          </a:p>
+        </p:txBody>
+      </p:sp>
+      <p:sp>
+        <p:nvSpPr>
+          <p:cNvPr id="9" name="TextBox 8"/>
+          <p:cNvSpPr txBox="1"/>
+          <p:nvPr/>
+        </p:nvSpPr>
+        <p:spPr>
+          <a:xfrm>
+            <a:off x="6583680" y="2468880"/>
+            <a:ext cx="4937760" cy="365760"/>
+          </a:xfrm>
+          <a:prstGeom prst="rect">
+            <a:avLst/>
+          </a:prstGeom>
+          <a:noFill/>
+        </p:spPr>
+        <p:txBody>
+          <a:bodyPr wrap="square" lIns="0" rIns="0" tIns="0" bIns="0" anchor="t">
+            <a:spAutoFit/>
+          </a:bodyPr>
+          <a:lstStyle/>
+          <a:p>
+            <a:pPr algn="l"/>
+            <a:r>
+              <a:rPr sz="1100" b="1" i="0">
+                <a:solidFill>
+                  <a:srgbClr val="57C1FF"/>
+                </a:solidFill>
+                <a:latin typeface="Inter"/>
+              </a:rPr>
+              <a:t>Next steps</a:t>
+            </a:r>
+          </a:p>
+        </p:txBody>
+      </p:sp>
+      <p:sp>
+        <p:nvSpPr>
+          <p:cNvPr id="10" name="TextBox 9"/>
+          <p:cNvSpPr txBox="1"/>
+          <p:nvPr/>
+        </p:nvSpPr>
+        <p:spPr>
+          <a:xfrm>
+            <a:off x="6583680" y="2926080"/>
+            <a:ext cx="4937760" cy="3200400"/>
+          </a:xfrm>
+          <a:prstGeom prst="rect">
+            <a:avLst/>
+          </a:prstGeom>
+          <a:noFill/>
+        </p:spPr>
+        <p:txBody>
+          <a:bodyPr wrap="square" lIns="0" rIns="0" tIns="0" bIns="0" anchor="t">
+            <a:spAutoFit/>
+          </a:bodyPr>
+          <a:lstStyle/>
+          <a:p>
+            <a:pPr algn="l"/>
+            <a:r>
+              <a:rPr sz="1200" b="0" i="0">
+                <a:solidFill>
+                  <a:srgbClr val="CDCDCD"/>
+                </a:solidFill>
+                <a:latin typeface="Inter"/>
+              </a:rPr>
               <a:t>•  Run the frozen held-out evaluation (TASK-043) and publish denominators.</a:t>
             </a:r>
           </a:p>
@@ -8766,7 +9407,7 @@
                 </a:solidFill>
                 <a:latin typeface="Inter"/>
               </a:rPr>
-              <a:t>•  Confirm organiser cutoff, channel and formats before submission.</a:t>
+              <a:t>•  Human Bangla review of copy and a timed study with real participants.</a:t>
             </a:r>
           </a:p>
           <a:p>
@@ -8778,19 +9419,7 @@
                 </a:solidFill>
                 <a:latin typeface="Inter"/>
               </a:rPr>
-              <a:t>•  Execute LINK-CHECK before sending and again after delivery.</a:t>
-            </a:r>
-          </a:p>
-          <a:p>
-            <a:pPr algn="l"/>
-            <a:r>
-              <a:rPr sz="1200" b="0" i="0">
-                <a:solidFill>
-                  <a:srgbClr val="CDCDCD"/>
-                </a:solidFill>
-                <a:latin typeface="Inter"/>
-              </a:rPr>
-              <a:t>•  Capture TASK-045 actual demo footage once the working build is signed off.</a:t>
+              <a:t>•  Configure a live AI provider within the USD 25 cap and deploy a hosted demo.</a:t>
             </a:r>
           </a:p>
           <a:p>

</xml_diff>